<commit_message>
Pitch deck: remove the honest-status slide
</commit_message>
<xml_diff>
--- a/docs/pitch/Sentinel_Pitch.pptx
+++ b/docs/pitch/Sentinel_Pitch.pptx
@@ -21,10 +21,9 @@
     <p:sldId id="269" r:id="rId15"/>
     <p:sldId id="270" r:id="rId16"/>
     <p:sldId id="271" r:id="rId17"/>
-    <p:sldId id="272" r:id="rId18"/>
   </p:sldIdLst>
   <p:notesMasterIdLst>
-    <p:notesMasterId r:id="rId19"/>
+    <p:notesMasterId r:id="rId18"/>
   </p:notesMasterIdLst>
   <p:sldSz cx="12192000" cy="6858000"/>
   <p:notesSz cx="6858000" cy="12192000"/>
@@ -1134,7 +1133,7 @@
           <a:p>
             <a:r>
               <a:rPr lang="en-US" dirty="0"/>
-              <a:t>Be direct about this slide. Proven: 392 automated tests at 94% coverage including a security group, the four attacks live on loopback, the ablation results on synthetic data, the console checked in a real browser. Not yet verified: a real gateway on bridge100, real delivery to Slack, Discord and Telegram, a real local LLM, and the false-alarm rate on a real network; each has a numbered item on the human-verification checklist. Roadmap: an autoencoder, per-device peer baselines, blocking with human approval, and a background service.</a:t>
+              <a:t>Close on the promise and the call to action: try it in five minutes with no network. Offer to run the live attack demo now. Questions.</a:t>
             </a:r>
             <a:endParaRPr lang="en-US" dirty="0"/>
           </a:p>
@@ -1158,94 +1157,6 @@
             <a:fld id="{F7021451-1387-4CA6-816F-3879F97B5CBC}" type="slidenum">
               <a:rPr lang="en-US"/>
               <a:t>16</a:t>
-            </a:fld>
-            <a:endParaRPr lang="en-US"/>
-          </a:p>
-        </p:txBody>
-      </p:sp>
-    </p:spTree>
-    <p:extLst>
-      <p:ext uri="{BB962C8B-B14F-4D97-AF65-F5344CB8AC3E}">
-        <p14:creationId xmlns:p14="http://schemas.microsoft.com/office/powerpoint/2010/main" val="1024086991"/>
-      </p:ext>
-    </p:extLst>
-  </p:cSld>
-  <p:clrMapOvr>
-    <a:masterClrMapping/>
-  </p:clrMapOvr>
-</p:notes>
-</file>
-
-<file path=ppt/notesSlides/notesSlide17.xml><?xml version="1.0" encoding="utf-8"?>
-<p:notes xmlns:a="http://schemas.openxmlformats.org/drawingml/2006/main" xmlns:r="http://schemas.openxmlformats.org/officeDocument/2006/relationships" xmlns:p="http://schemas.openxmlformats.org/presentationml/2006/main">
-  <p:cSld>
-    <p:spTree>
-      <p:nvGrpSpPr>
-        <p:cNvPr id="1" name=""/>
-        <p:cNvGrpSpPr/>
-        <p:nvPr/>
-      </p:nvGrpSpPr>
-      <p:grpSpPr>
-        <a:xfrm>
-          <a:off x="0" y="0"/>
-          <a:ext cx="0" cy="0"/>
-          <a:chOff x="0" y="0"/>
-          <a:chExt cx="0" cy="0"/>
-        </a:xfrm>
-      </p:grpSpPr>
-      <p:sp>
-        <p:nvSpPr>
-          <p:cNvPr id="2" name="Slide Image Placeholder 1"/>
-          <p:cNvSpPr>
-            <a:spLocks noGrp="1" noRot="1" noChangeAspect="1"/>
-          </p:cNvSpPr>
-          <p:nvPr>
-            <p:ph type="sldImg"/>
-          </p:nvPr>
-        </p:nvSpPr>
-        <p:spPr/>
-      </p:sp>
-      <p:sp>
-        <p:nvSpPr>
-          <p:cNvPr id="3" name="Notes Placeholder 2"/>
-          <p:cNvSpPr>
-            <a:spLocks noGrp="1"/>
-          </p:cNvSpPr>
-          <p:nvPr>
-            <p:ph type="body" idx="1"/>
-          </p:nvPr>
-        </p:nvSpPr>
-        <p:spPr/>
-        <p:txBody>
-          <a:bodyPr/>
-          <a:lstStyle/>
-          <a:p>
-            <a:r>
-              <a:rPr lang="en-US" dirty="0"/>
-              <a:t>Close on the promise and the call to action: try it in five minutes with no network. Offer to run the live attack demo now. Questions.</a:t>
-            </a:r>
-            <a:endParaRPr lang="en-US" dirty="0"/>
-          </a:p>
-        </p:txBody>
-      </p:sp>
-      <p:sp>
-        <p:nvSpPr>
-          <p:cNvPr id="4" name="Slide Number Placeholder 3"/>
-          <p:cNvSpPr>
-            <a:spLocks noGrp="1"/>
-          </p:cNvSpPr>
-          <p:nvPr>
-            <p:ph type="sldNum" sz="quarter" idx="10"/>
-          </p:nvPr>
-        </p:nvSpPr>
-        <p:spPr/>
-        <p:txBody>
-          <a:bodyPr/>
-          <a:lstStyle/>
-          <a:p>
-            <a:fld id="{F7021451-1387-4CA6-816F-3879F97B5CBC}" type="slidenum">
-              <a:rPr lang="en-US"/>
-              <a:t>17</a:t>
             </a:fld>
             <a:endParaRPr lang="en-US"/>
           </a:p>
@@ -10010,1355 +9921,6 @@
 <file path=ppt/slides/slide16.xml><?xml version="1.0" encoding="utf-8"?>
 <p:sld xmlns:a="http://schemas.openxmlformats.org/drawingml/2006/main" xmlns:r="http://schemas.openxmlformats.org/officeDocument/2006/relationships" xmlns:p="http://schemas.openxmlformats.org/presentationml/2006/main">
   <p:cSld name="Slide 16">
-    <p:spTree>
-      <p:nvGrpSpPr>
-        <p:cNvPr id="1" name=""/>
-        <p:cNvGrpSpPr/>
-        <p:nvPr/>
-      </p:nvGrpSpPr>
-      <p:grpSpPr>
-        <a:xfrm>
-          <a:off x="0" y="0"/>
-          <a:ext cx="0" cy="0"/>
-          <a:chOff x="0" y="0"/>
-          <a:chExt cx="0" cy="0"/>
-        </a:xfrm>
-      </p:grpSpPr>
-      <p:sp>
-        <p:nvSpPr>
-          <p:cNvPr id="2" name="Text 3"/>
-          <p:cNvSpPr/>
-          <p:nvPr>
-            <p:ph idx="103" type="title" hasCustomPrompt="1"/>
-          </p:nvPr>
-        </p:nvSpPr>
-        <p:spPr>
-          <a:xfrm>
-            <a:off x="548640" y="566928"/>
-            <a:ext cx="11064240" cy="868680"/>
-          </a:xfrm>
-          <a:prstGeom prst="rect">
-            <a:avLst/>
-          </a:prstGeom>
-          <a:noFill/>
-          <a:ln/>
-        </p:spPr>
-        <p:txBody>
-          <a:bodyPr wrap="square" lIns="0" tIns="0" rIns="0" bIns="0" rtlCol="0" anchor="t"/>
-          <a:lstStyle/>
-          <a:p>
-            <a:pPr algn="l" indent="0" marL="0">
-              <a:buNone/>
-            </a:pPr>
-            <a:r>
-              <a:rPr lang="en-US" sz="2800" b="1" dirty="0">
-                <a:solidFill>
-                  <a:srgbClr val="E6EAEE"/>
-                </a:solidFill>
-                <a:latin typeface="Calibri" pitchFamily="34" charset="0"/>
-                <a:ea typeface="Calibri" pitchFamily="34" charset="-122"/>
-                <a:cs typeface="Calibri" pitchFamily="34" charset="-120"/>
-              </a:rPr>
-              <a:t>Where it stands: what is proven, what is not yet, what is next</a:t>
-            </a:r>
-            <a:endParaRPr lang="en-US" sz="2800" dirty="0"/>
-          </a:p>
-        </p:txBody>
-      </p:sp>
-      <p:sp>
-        <p:nvSpPr>
-          <p:cNvPr id="4" name="Text 1"/>
-          <p:cNvSpPr txBox="1"/>
-          <p:nvPr/>
-        </p:nvSpPr>
-        <p:spPr>
-          <a:xfrm>
-            <a:off x="548640" y="274320"/>
-            <a:ext cx="7315200" cy="256032"/>
-          </a:xfrm>
-          <a:prstGeom prst="rect">
-            <a:avLst/>
-          </a:prstGeom>
-          <a:noFill/>
-          <a:ln/>
-        </p:spPr>
-        <p:txBody>
-          <a:bodyPr wrap="square" lIns="0" tIns="0" rIns="0" bIns="0" rtlCol="0" anchor="ctr"/>
-          <a:lstStyle/>
-          <a:p>
-            <a:pPr indent="0" marL="0">
-              <a:buNone/>
-            </a:pPr>
-            <a:r>
-              <a:rPr lang="en-US" sz="1100" b="1" spc="300" kern="0" dirty="0">
-                <a:solidFill>
-                  <a:srgbClr val="C4403F"/>
-                </a:solidFill>
-                <a:latin typeface="Courier New" pitchFamily="34" charset="0"/>
-                <a:ea typeface="Courier New" pitchFamily="34" charset="-122"/>
-                <a:cs typeface="Courier New" pitchFamily="34" charset="-120"/>
-              </a:rPr>
-              <a:t>15  /  HONEST STATUS</a:t>
-            </a:r>
-            <a:endParaRPr lang="en-US" sz="1100" dirty="0"/>
-          </a:p>
-        </p:txBody>
-      </p:sp>
-      <p:sp>
-        <p:nvSpPr>
-          <p:cNvPr id="5" name="col"/>
-          <p:cNvSpPr/>
-          <p:nvPr/>
-        </p:nvSpPr>
-        <p:spPr>
-          <a:xfrm>
-            <a:off x="548640" y="1645920"/>
-            <a:ext cx="3611880" cy="4389120"/>
-          </a:xfrm>
-          <a:prstGeom prst="rect">
-            <a:avLst/>
-          </a:prstGeom>
-          <a:solidFill>
-            <a:srgbClr val="12161A"/>
-          </a:solidFill>
-          <a:ln w="12700">
-            <a:solidFill>
-              <a:srgbClr val="232A31"/>
-            </a:solidFill>
-            <a:prstDash val="solid"/>
-          </a:ln>
-        </p:spPr>
-      </p:sp>
-      <p:sp>
-        <p:nvSpPr>
-          <p:cNvPr id="6" name="col-top"/>
-          <p:cNvSpPr/>
-          <p:nvPr/>
-        </p:nvSpPr>
-        <p:spPr>
-          <a:xfrm>
-            <a:off x="548640" y="1645920"/>
-            <a:ext cx="3611880" cy="64008"/>
-          </a:xfrm>
-          <a:prstGeom prst="rect">
-            <a:avLst/>
-          </a:prstGeom>
-          <a:solidFill>
-            <a:srgbClr val="5A9E84"/>
-          </a:solidFill>
-          <a:ln/>
-        </p:spPr>
-      </p:sp>
-      <p:sp>
-        <p:nvSpPr>
-          <p:cNvPr id="7" name="Text 4"/>
-          <p:cNvSpPr txBox="1"/>
-          <p:nvPr/>
-        </p:nvSpPr>
-        <p:spPr>
-          <a:xfrm>
-            <a:off x="777240" y="1874520"/>
-            <a:ext cx="3108960" cy="274320"/>
-          </a:xfrm>
-          <a:prstGeom prst="rect">
-            <a:avLst/>
-          </a:prstGeom>
-          <a:noFill/>
-          <a:ln/>
-        </p:spPr>
-        <p:txBody>
-          <a:bodyPr wrap="square" lIns="0" tIns="0" rIns="0" bIns="0" rtlCol="0" anchor="ctr"/>
-          <a:lstStyle/>
-          <a:p>
-            <a:pPr indent="0" marL="0">
-              <a:buNone/>
-            </a:pPr>
-            <a:r>
-              <a:rPr lang="en-US" sz="1200" b="1" spc="300" kern="0" dirty="0">
-                <a:solidFill>
-                  <a:srgbClr val="5A9E84"/>
-                </a:solidFill>
-                <a:latin typeface="Courier New" pitchFamily="34" charset="0"/>
-                <a:ea typeface="Courier New" pitchFamily="34" charset="-122"/>
-                <a:cs typeface="Courier New" pitchFamily="34" charset="-120"/>
-              </a:rPr>
-              <a:t>PROVEN</a:t>
-            </a:r>
-            <a:endParaRPr lang="en-US" sz="1200" dirty="0"/>
-          </a:p>
-        </p:txBody>
-      </p:sp>
-      <p:sp>
-        <p:nvSpPr>
-          <p:cNvPr id="8" name="dot"/>
-          <p:cNvSpPr/>
-          <p:nvPr/>
-        </p:nvSpPr>
-        <p:spPr>
-          <a:xfrm>
-            <a:off x="777240" y="2423160"/>
-            <a:ext cx="91440" cy="91440"/>
-          </a:xfrm>
-          <a:prstGeom prst="rect">
-            <a:avLst/>
-          </a:prstGeom>
-          <a:solidFill>
-            <a:srgbClr val="5A9E84"/>
-          </a:solidFill>
-          <a:ln/>
-        </p:spPr>
-      </p:sp>
-      <p:sp>
-        <p:nvSpPr>
-          <p:cNvPr id="9" name="Text 6"/>
-          <p:cNvSpPr txBox="1"/>
-          <p:nvPr/>
-        </p:nvSpPr>
-        <p:spPr>
-          <a:xfrm>
-            <a:off x="1033272" y="2331720"/>
-            <a:ext cx="2926080" cy="566928"/>
-          </a:xfrm>
-          <a:prstGeom prst="rect">
-            <a:avLst/>
-          </a:prstGeom>
-          <a:noFill/>
-          <a:ln/>
-        </p:spPr>
-        <p:txBody>
-          <a:bodyPr wrap="square" lIns="0" tIns="0" rIns="0" bIns="0" rtlCol="0" anchor="t"/>
-          <a:lstStyle/>
-          <a:p>
-            <a:pPr indent="0" marL="0">
-              <a:buNone/>
-            </a:pPr>
-            <a:r>
-              <a:rPr lang="en-US" sz="1350" dirty="0">
-                <a:solidFill>
-                  <a:srgbClr val="CBD2D9"/>
-                </a:solidFill>
-                <a:latin typeface="Calibri" pitchFamily="34" charset="0"/>
-                <a:ea typeface="Calibri" pitchFamily="34" charset="-122"/>
-                <a:cs typeface="Calibri" pitchFamily="34" charset="-120"/>
-              </a:rPr>
-              <a:t>392 automated tests, 94% coverage</a:t>
-            </a:r>
-            <a:endParaRPr lang="en-US" sz="1350" dirty="0"/>
-          </a:p>
-        </p:txBody>
-      </p:sp>
-      <p:sp>
-        <p:nvSpPr>
-          <p:cNvPr id="10" name="dot"/>
-          <p:cNvSpPr/>
-          <p:nvPr/>
-        </p:nvSpPr>
-        <p:spPr>
-          <a:xfrm>
-            <a:off x="777240" y="3054096"/>
-            <a:ext cx="91440" cy="91440"/>
-          </a:xfrm>
-          <a:prstGeom prst="rect">
-            <a:avLst/>
-          </a:prstGeom>
-          <a:solidFill>
-            <a:srgbClr val="5A9E84"/>
-          </a:solidFill>
-          <a:ln/>
-        </p:spPr>
-      </p:sp>
-      <p:sp>
-        <p:nvSpPr>
-          <p:cNvPr id="11" name="Text 8"/>
-          <p:cNvSpPr txBox="1"/>
-          <p:nvPr/>
-        </p:nvSpPr>
-        <p:spPr>
-          <a:xfrm>
-            <a:off x="1033272" y="2962656"/>
-            <a:ext cx="2926080" cy="566928"/>
-          </a:xfrm>
-          <a:prstGeom prst="rect">
-            <a:avLst/>
-          </a:prstGeom>
-          <a:noFill/>
-          <a:ln/>
-        </p:spPr>
-        <p:txBody>
-          <a:bodyPr wrap="square" lIns="0" tIns="0" rIns="0" bIns="0" rtlCol="0" anchor="t"/>
-          <a:lstStyle/>
-          <a:p>
-            <a:pPr indent="0" marL="0">
-              <a:buNone/>
-            </a:pPr>
-            <a:r>
-              <a:rPr lang="en-US" sz="1350" dirty="0">
-                <a:solidFill>
-                  <a:srgbClr val="CBD2D9"/>
-                </a:solidFill>
-                <a:latin typeface="Calibri" pitchFamily="34" charset="0"/>
-                <a:ea typeface="Calibri" pitchFamily="34" charset="-122"/>
-                <a:cs typeface="Calibri" pitchFamily="34" charset="-120"/>
-              </a:rPr>
-              <a:t>Security test group, strict types, dead-code scan</a:t>
-            </a:r>
-            <a:endParaRPr lang="en-US" sz="1350" dirty="0"/>
-          </a:p>
-        </p:txBody>
-      </p:sp>
-      <p:sp>
-        <p:nvSpPr>
-          <p:cNvPr id="12" name="dot"/>
-          <p:cNvSpPr/>
-          <p:nvPr/>
-        </p:nvSpPr>
-        <p:spPr>
-          <a:xfrm>
-            <a:off x="777240" y="3685032"/>
-            <a:ext cx="91440" cy="91440"/>
-          </a:xfrm>
-          <a:prstGeom prst="rect">
-            <a:avLst/>
-          </a:prstGeom>
-          <a:solidFill>
-            <a:srgbClr val="5A9E84"/>
-          </a:solidFill>
-          <a:ln/>
-        </p:spPr>
-      </p:sp>
-      <p:sp>
-        <p:nvSpPr>
-          <p:cNvPr id="13" name="Text 10"/>
-          <p:cNvSpPr txBox="1"/>
-          <p:nvPr/>
-        </p:nvSpPr>
-        <p:spPr>
-          <a:xfrm>
-            <a:off x="1033272" y="3593592"/>
-            <a:ext cx="2926080" cy="566928"/>
-          </a:xfrm>
-          <a:prstGeom prst="rect">
-            <a:avLst/>
-          </a:prstGeom>
-          <a:noFill/>
-          <a:ln/>
-        </p:spPr>
-        <p:txBody>
-          <a:bodyPr wrap="square" lIns="0" tIns="0" rIns="0" bIns="0" rtlCol="0" anchor="t"/>
-          <a:lstStyle/>
-          <a:p>
-            <a:pPr indent="0" marL="0">
-              <a:buNone/>
-            </a:pPr>
-            <a:r>
-              <a:rPr lang="en-US" sz="1350" dirty="0">
-                <a:solidFill>
-                  <a:srgbClr val="CBD2D9"/>
-                </a:solidFill>
-                <a:latin typeface="Calibri" pitchFamily="34" charset="0"/>
-                <a:ea typeface="Calibri" pitchFamily="34" charset="-122"/>
-                <a:cs typeface="Calibri" pitchFamily="34" charset="-120"/>
-              </a:rPr>
-              <a:t>4 / 4 live attacks on loopback, control quiet</a:t>
-            </a:r>
-            <a:endParaRPr lang="en-US" sz="1350" dirty="0"/>
-          </a:p>
-        </p:txBody>
-      </p:sp>
-      <p:sp>
-        <p:nvSpPr>
-          <p:cNvPr id="14" name="dot"/>
-          <p:cNvSpPr/>
-          <p:nvPr/>
-        </p:nvSpPr>
-        <p:spPr>
-          <a:xfrm>
-            <a:off x="777240" y="4315968"/>
-            <a:ext cx="91440" cy="91440"/>
-          </a:xfrm>
-          <a:prstGeom prst="rect">
-            <a:avLst/>
-          </a:prstGeom>
-          <a:solidFill>
-            <a:srgbClr val="5A9E84"/>
-          </a:solidFill>
-          <a:ln/>
-        </p:spPr>
-      </p:sp>
-      <p:sp>
-        <p:nvSpPr>
-          <p:cNvPr id="15" name="Text 12"/>
-          <p:cNvSpPr txBox="1"/>
-          <p:nvPr/>
-        </p:nvSpPr>
-        <p:spPr>
-          <a:xfrm>
-            <a:off x="1033272" y="4224528"/>
-            <a:ext cx="2926080" cy="566928"/>
-          </a:xfrm>
-          <a:prstGeom prst="rect">
-            <a:avLst/>
-          </a:prstGeom>
-          <a:noFill/>
-          <a:ln/>
-        </p:spPr>
-        <p:txBody>
-          <a:bodyPr wrap="square" lIns="0" tIns="0" rIns="0" bIns="0" rtlCol="0" anchor="t"/>
-          <a:lstStyle/>
-          <a:p>
-            <a:pPr indent="0" marL="0">
-              <a:buNone/>
-            </a:pPr>
-            <a:r>
-              <a:rPr lang="en-US" sz="1350" dirty="0">
-                <a:solidFill>
-                  <a:srgbClr val="CBD2D9"/>
-                </a:solidFill>
-                <a:latin typeface="Calibri" pitchFamily="34" charset="0"/>
-                <a:ea typeface="Calibri" pitchFamily="34" charset="-122"/>
-                <a:cs typeface="Calibri" pitchFamily="34" charset="-120"/>
-              </a:rPr>
-              <a:t>Both models measured against the rules alone</a:t>
-            </a:r>
-            <a:endParaRPr lang="en-US" sz="1350" dirty="0"/>
-          </a:p>
-        </p:txBody>
-      </p:sp>
-      <p:sp>
-        <p:nvSpPr>
-          <p:cNvPr id="16" name="dot"/>
-          <p:cNvSpPr/>
-          <p:nvPr/>
-        </p:nvSpPr>
-        <p:spPr>
-          <a:xfrm>
-            <a:off x="777240" y="4946904"/>
-            <a:ext cx="91440" cy="91440"/>
-          </a:xfrm>
-          <a:prstGeom prst="rect">
-            <a:avLst/>
-          </a:prstGeom>
-          <a:solidFill>
-            <a:srgbClr val="5A9E84"/>
-          </a:solidFill>
-          <a:ln/>
-        </p:spPr>
-      </p:sp>
-      <p:sp>
-        <p:nvSpPr>
-          <p:cNvPr id="17" name="Text 14"/>
-          <p:cNvSpPr txBox="1"/>
-          <p:nvPr/>
-        </p:nvSpPr>
-        <p:spPr>
-          <a:xfrm>
-            <a:off x="1033272" y="4855464"/>
-            <a:ext cx="2926080" cy="566928"/>
-          </a:xfrm>
-          <a:prstGeom prst="rect">
-            <a:avLst/>
-          </a:prstGeom>
-          <a:noFill/>
-          <a:ln/>
-        </p:spPr>
-        <p:txBody>
-          <a:bodyPr wrap="square" lIns="0" tIns="0" rIns="0" bIns="0" rtlCol="0" anchor="t"/>
-          <a:lstStyle/>
-          <a:p>
-            <a:pPr indent="0" marL="0">
-              <a:buNone/>
-            </a:pPr>
-            <a:r>
-              <a:rPr lang="en-US" sz="1350" dirty="0">
-                <a:solidFill>
-                  <a:srgbClr val="CBD2D9"/>
-                </a:solidFill>
-                <a:latin typeface="Calibri" pitchFamily="34" charset="0"/>
-                <a:ea typeface="Calibri" pitchFamily="34" charset="-122"/>
-                <a:cs typeface="Calibri" pitchFamily="34" charset="-120"/>
-              </a:rPr>
-              <a:t>Console checked in a real browser</a:t>
-            </a:r>
-            <a:endParaRPr lang="en-US" sz="1350" dirty="0"/>
-          </a:p>
-        </p:txBody>
-      </p:sp>
-      <p:sp>
-        <p:nvSpPr>
-          <p:cNvPr id="18" name="dot"/>
-          <p:cNvSpPr/>
-          <p:nvPr/>
-        </p:nvSpPr>
-        <p:spPr>
-          <a:xfrm>
-            <a:off x="777240" y="5577840"/>
-            <a:ext cx="91440" cy="91440"/>
-          </a:xfrm>
-          <a:prstGeom prst="rect">
-            <a:avLst/>
-          </a:prstGeom>
-          <a:solidFill>
-            <a:srgbClr val="5A9E84"/>
-          </a:solidFill>
-          <a:ln/>
-        </p:spPr>
-      </p:sp>
-      <p:sp>
-        <p:nvSpPr>
-          <p:cNvPr id="19" name="Text 16"/>
-          <p:cNvSpPr txBox="1"/>
-          <p:nvPr/>
-        </p:nvSpPr>
-        <p:spPr>
-          <a:xfrm>
-            <a:off x="1033272" y="5486400"/>
-            <a:ext cx="2926080" cy="566928"/>
-          </a:xfrm>
-          <a:prstGeom prst="rect">
-            <a:avLst/>
-          </a:prstGeom>
-          <a:noFill/>
-          <a:ln/>
-        </p:spPr>
-        <p:txBody>
-          <a:bodyPr wrap="square" lIns="0" tIns="0" rIns="0" bIns="0" rtlCol="0" anchor="t"/>
-          <a:lstStyle/>
-          <a:p>
-            <a:pPr indent="0" marL="0">
-              <a:buNone/>
-            </a:pPr>
-            <a:r>
-              <a:rPr lang="en-US" sz="1350" dirty="0">
-                <a:solidFill>
-                  <a:srgbClr val="CBD2D9"/>
-                </a:solidFill>
-                <a:latin typeface="Calibri" pitchFamily="34" charset="0"/>
-                <a:ea typeface="Calibri" pitchFamily="34" charset="-122"/>
-                <a:cs typeface="Calibri" pitchFamily="34" charset="-120"/>
-              </a:rPr>
-              <a:t>Installs from a fresh clone</a:t>
-            </a:r>
-            <a:endParaRPr lang="en-US" sz="1350" dirty="0"/>
-          </a:p>
-        </p:txBody>
-      </p:sp>
-      <p:sp>
-        <p:nvSpPr>
-          <p:cNvPr id="20" name="col"/>
-          <p:cNvSpPr/>
-          <p:nvPr/>
-        </p:nvSpPr>
-        <p:spPr>
-          <a:xfrm>
-            <a:off x="4297680" y="1645920"/>
-            <a:ext cx="3611880" cy="4389120"/>
-          </a:xfrm>
-          <a:prstGeom prst="rect">
-            <a:avLst/>
-          </a:prstGeom>
-          <a:solidFill>
-            <a:srgbClr val="12161A"/>
-          </a:solidFill>
-          <a:ln w="12700">
-            <a:solidFill>
-              <a:srgbClr val="232A31"/>
-            </a:solidFill>
-            <a:prstDash val="solid"/>
-          </a:ln>
-        </p:spPr>
-      </p:sp>
-      <p:sp>
-        <p:nvSpPr>
-          <p:cNvPr id="21" name="col-top"/>
-          <p:cNvSpPr/>
-          <p:nvPr/>
-        </p:nvSpPr>
-        <p:spPr>
-          <a:xfrm>
-            <a:off x="4297680" y="1645920"/>
-            <a:ext cx="3611880" cy="64008"/>
-          </a:xfrm>
-          <a:prstGeom prst="rect">
-            <a:avLst/>
-          </a:prstGeom>
-          <a:solidFill>
-            <a:srgbClr val="B8993B"/>
-          </a:solidFill>
-          <a:ln/>
-        </p:spPr>
-      </p:sp>
-      <p:sp>
-        <p:nvSpPr>
-          <p:cNvPr id="22" name="Text 19"/>
-          <p:cNvSpPr txBox="1"/>
-          <p:nvPr/>
-        </p:nvSpPr>
-        <p:spPr>
-          <a:xfrm>
-            <a:off x="4526280" y="1874520"/>
-            <a:ext cx="3108960" cy="274320"/>
-          </a:xfrm>
-          <a:prstGeom prst="rect">
-            <a:avLst/>
-          </a:prstGeom>
-          <a:noFill/>
-          <a:ln/>
-        </p:spPr>
-        <p:txBody>
-          <a:bodyPr wrap="square" lIns="0" tIns="0" rIns="0" bIns="0" rtlCol="0" anchor="ctr"/>
-          <a:lstStyle/>
-          <a:p>
-            <a:pPr indent="0" marL="0">
-              <a:buNone/>
-            </a:pPr>
-            <a:r>
-              <a:rPr lang="en-US" sz="1200" b="1" spc="300" kern="0" dirty="0">
-                <a:solidFill>
-                  <a:srgbClr val="B8993B"/>
-                </a:solidFill>
-                <a:latin typeface="Courier New" pitchFamily="34" charset="0"/>
-                <a:ea typeface="Courier New" pitchFamily="34" charset="-122"/>
-                <a:cs typeface="Courier New" pitchFamily="34" charset="-120"/>
-              </a:rPr>
-              <a:t>NOT YET VERIFIED</a:t>
-            </a:r>
-            <a:endParaRPr lang="en-US" sz="1200" dirty="0"/>
-          </a:p>
-        </p:txBody>
-      </p:sp>
-      <p:sp>
-        <p:nvSpPr>
-          <p:cNvPr id="23" name="dot"/>
-          <p:cNvSpPr/>
-          <p:nvPr/>
-        </p:nvSpPr>
-        <p:spPr>
-          <a:xfrm>
-            <a:off x="4526280" y="2423160"/>
-            <a:ext cx="91440" cy="91440"/>
-          </a:xfrm>
-          <a:prstGeom prst="rect">
-            <a:avLst/>
-          </a:prstGeom>
-          <a:solidFill>
-            <a:srgbClr val="B8993B"/>
-          </a:solidFill>
-          <a:ln/>
-        </p:spPr>
-      </p:sp>
-      <p:sp>
-        <p:nvSpPr>
-          <p:cNvPr id="24" name="Text 21"/>
-          <p:cNvSpPr txBox="1"/>
-          <p:nvPr/>
-        </p:nvSpPr>
-        <p:spPr>
-          <a:xfrm>
-            <a:off x="4782312" y="2331720"/>
-            <a:ext cx="2926080" cy="566928"/>
-          </a:xfrm>
-          <a:prstGeom prst="rect">
-            <a:avLst/>
-          </a:prstGeom>
-          <a:noFill/>
-          <a:ln/>
-        </p:spPr>
-        <p:txBody>
-          <a:bodyPr wrap="square" lIns="0" tIns="0" rIns="0" bIns="0" rtlCol="0" anchor="t"/>
-          <a:lstStyle/>
-          <a:p>
-            <a:pPr indent="0" marL="0">
-              <a:buNone/>
-            </a:pPr>
-            <a:r>
-              <a:rPr lang="en-US" sz="1350" dirty="0">
-                <a:solidFill>
-                  <a:srgbClr val="CBD2D9"/>
-                </a:solidFill>
-                <a:latin typeface="Calibri" pitchFamily="34" charset="0"/>
-                <a:ea typeface="Calibri" pitchFamily="34" charset="-122"/>
-                <a:cs typeface="Calibri" pitchFamily="34" charset="-120"/>
-              </a:rPr>
-              <a:t>Real gateway capture on bridge100</a:t>
-            </a:r>
-            <a:endParaRPr lang="en-US" sz="1350" dirty="0"/>
-          </a:p>
-        </p:txBody>
-      </p:sp>
-      <p:sp>
-        <p:nvSpPr>
-          <p:cNvPr id="25" name="dot"/>
-          <p:cNvSpPr/>
-          <p:nvPr/>
-        </p:nvSpPr>
-        <p:spPr>
-          <a:xfrm>
-            <a:off x="4526280" y="3054096"/>
-            <a:ext cx="91440" cy="91440"/>
-          </a:xfrm>
-          <a:prstGeom prst="rect">
-            <a:avLst/>
-          </a:prstGeom>
-          <a:solidFill>
-            <a:srgbClr val="B8993B"/>
-          </a:solidFill>
-          <a:ln/>
-        </p:spPr>
-      </p:sp>
-      <p:sp>
-        <p:nvSpPr>
-          <p:cNvPr id="26" name="Text 23"/>
-          <p:cNvSpPr txBox="1"/>
-          <p:nvPr/>
-        </p:nvSpPr>
-        <p:spPr>
-          <a:xfrm>
-            <a:off x="4782312" y="2962656"/>
-            <a:ext cx="2926080" cy="566928"/>
-          </a:xfrm>
-          <a:prstGeom prst="rect">
-            <a:avLst/>
-          </a:prstGeom>
-          <a:noFill/>
-          <a:ln/>
-        </p:spPr>
-        <p:txBody>
-          <a:bodyPr wrap="square" lIns="0" tIns="0" rIns="0" bIns="0" rtlCol="0" anchor="t"/>
-          <a:lstStyle/>
-          <a:p>
-            <a:pPr indent="0" marL="0">
-              <a:buNone/>
-            </a:pPr>
-            <a:r>
-              <a:rPr lang="en-US" sz="1350" dirty="0">
-                <a:solidFill>
-                  <a:srgbClr val="CBD2D9"/>
-                </a:solidFill>
-                <a:latin typeface="Calibri" pitchFamily="34" charset="0"/>
-                <a:ea typeface="Calibri" pitchFamily="34" charset="-122"/>
-                <a:cs typeface="Calibri" pitchFamily="34" charset="-120"/>
-              </a:rPr>
-              <a:t>Real Slack, Discord, Telegram delivery</a:t>
-            </a:r>
-            <a:endParaRPr lang="en-US" sz="1350" dirty="0"/>
-          </a:p>
-        </p:txBody>
-      </p:sp>
-      <p:sp>
-        <p:nvSpPr>
-          <p:cNvPr id="27" name="dot"/>
-          <p:cNvSpPr/>
-          <p:nvPr/>
-        </p:nvSpPr>
-        <p:spPr>
-          <a:xfrm>
-            <a:off x="4526280" y="3685032"/>
-            <a:ext cx="91440" cy="91440"/>
-          </a:xfrm>
-          <a:prstGeom prst="rect">
-            <a:avLst/>
-          </a:prstGeom>
-          <a:solidFill>
-            <a:srgbClr val="B8993B"/>
-          </a:solidFill>
-          <a:ln/>
-        </p:spPr>
-      </p:sp>
-      <p:sp>
-        <p:nvSpPr>
-          <p:cNvPr id="28" name="Text 25"/>
-          <p:cNvSpPr txBox="1"/>
-          <p:nvPr/>
-        </p:nvSpPr>
-        <p:spPr>
-          <a:xfrm>
-            <a:off x="4782312" y="3593592"/>
-            <a:ext cx="2926080" cy="566928"/>
-          </a:xfrm>
-          <a:prstGeom prst="rect">
-            <a:avLst/>
-          </a:prstGeom>
-          <a:noFill/>
-          <a:ln/>
-        </p:spPr>
-        <p:txBody>
-          <a:bodyPr wrap="square" lIns="0" tIns="0" rIns="0" bIns="0" rtlCol="0" anchor="t"/>
-          <a:lstStyle/>
-          <a:p>
-            <a:pPr indent="0" marL="0">
-              <a:buNone/>
-            </a:pPr>
-            <a:r>
-              <a:rPr lang="en-US" sz="1350" dirty="0">
-                <a:solidFill>
-                  <a:srgbClr val="CBD2D9"/>
-                </a:solidFill>
-                <a:latin typeface="Calibri" pitchFamily="34" charset="0"/>
-                <a:ea typeface="Calibri" pitchFamily="34" charset="-122"/>
-                <a:cs typeface="Calibri" pitchFamily="34" charset="-120"/>
-              </a:rPr>
-              <a:t>A real local LLM (Ollama, llama.cpp)</a:t>
-            </a:r>
-            <a:endParaRPr lang="en-US" sz="1350" dirty="0"/>
-          </a:p>
-        </p:txBody>
-      </p:sp>
-      <p:sp>
-        <p:nvSpPr>
-          <p:cNvPr id="29" name="dot"/>
-          <p:cNvSpPr/>
-          <p:nvPr/>
-        </p:nvSpPr>
-        <p:spPr>
-          <a:xfrm>
-            <a:off x="4526280" y="4315968"/>
-            <a:ext cx="91440" cy="91440"/>
-          </a:xfrm>
-          <a:prstGeom prst="rect">
-            <a:avLst/>
-          </a:prstGeom>
-          <a:solidFill>
-            <a:srgbClr val="B8993B"/>
-          </a:solidFill>
-          <a:ln/>
-        </p:spPr>
-      </p:sp>
-      <p:sp>
-        <p:nvSpPr>
-          <p:cNvPr id="30" name="Text 27"/>
-          <p:cNvSpPr txBox="1"/>
-          <p:nvPr/>
-        </p:nvSpPr>
-        <p:spPr>
-          <a:xfrm>
-            <a:off x="4782312" y="4224528"/>
-            <a:ext cx="2926080" cy="566928"/>
-          </a:xfrm>
-          <a:prstGeom prst="rect">
-            <a:avLst/>
-          </a:prstGeom>
-          <a:noFill/>
-          <a:ln/>
-        </p:spPr>
-        <p:txBody>
-          <a:bodyPr wrap="square" lIns="0" tIns="0" rIns="0" bIns="0" rtlCol="0" anchor="t"/>
-          <a:lstStyle/>
-          <a:p>
-            <a:pPr indent="0" marL="0">
-              <a:buNone/>
-            </a:pPr>
-            <a:r>
-              <a:rPr lang="en-US" sz="1350" dirty="0">
-                <a:solidFill>
-                  <a:srgbClr val="CBD2D9"/>
-                </a:solidFill>
-                <a:latin typeface="Calibri" pitchFamily="34" charset="0"/>
-                <a:ea typeface="Calibri" pitchFamily="34" charset="-122"/>
-                <a:cs typeface="Calibri" pitchFamily="34" charset="-120"/>
-              </a:rPr>
-              <a:t>False-alarm rate on a real network</a:t>
-            </a:r>
-            <a:endParaRPr lang="en-US" sz="1350" dirty="0"/>
-          </a:p>
-        </p:txBody>
-      </p:sp>
-      <p:sp>
-        <p:nvSpPr>
-          <p:cNvPr id="31" name="dot"/>
-          <p:cNvSpPr/>
-          <p:nvPr/>
-        </p:nvSpPr>
-        <p:spPr>
-          <a:xfrm>
-            <a:off x="4526280" y="4946904"/>
-            <a:ext cx="91440" cy="91440"/>
-          </a:xfrm>
-          <a:prstGeom prst="rect">
-            <a:avLst/>
-          </a:prstGeom>
-          <a:solidFill>
-            <a:srgbClr val="B8993B"/>
-          </a:solidFill>
-          <a:ln/>
-        </p:spPr>
-      </p:sp>
-      <p:sp>
-        <p:nvSpPr>
-          <p:cNvPr id="32" name="Text 29"/>
-          <p:cNvSpPr txBox="1"/>
-          <p:nvPr/>
-        </p:nvSpPr>
-        <p:spPr>
-          <a:xfrm>
-            <a:off x="4782312" y="4855464"/>
-            <a:ext cx="2926080" cy="566928"/>
-          </a:xfrm>
-          <a:prstGeom prst="rect">
-            <a:avLst/>
-          </a:prstGeom>
-          <a:noFill/>
-          <a:ln/>
-        </p:spPr>
-        <p:txBody>
-          <a:bodyPr wrap="square" lIns="0" tIns="0" rIns="0" bIns="0" rtlCol="0" anchor="t"/>
-          <a:lstStyle/>
-          <a:p>
-            <a:pPr indent="0" marL="0">
-              <a:buNone/>
-            </a:pPr>
-            <a:r>
-              <a:rPr lang="en-US" sz="1350" dirty="0">
-                <a:solidFill>
-                  <a:srgbClr val="CBD2D9"/>
-                </a:solidFill>
-                <a:latin typeface="Calibri" pitchFamily="34" charset="0"/>
-                <a:ea typeface="Calibri" pitchFamily="34" charset="-122"/>
-                <a:cs typeface="Calibri" pitchFamily="34" charset="-120"/>
-              </a:rPr>
-              <a:t>sudo file-ownership handback on hardware</a:t>
-            </a:r>
-            <a:endParaRPr lang="en-US" sz="1350" dirty="0"/>
-          </a:p>
-        </p:txBody>
-      </p:sp>
-      <p:sp>
-        <p:nvSpPr>
-          <p:cNvPr id="33" name="col"/>
-          <p:cNvSpPr/>
-          <p:nvPr/>
-        </p:nvSpPr>
-        <p:spPr>
-          <a:xfrm>
-            <a:off x="8046720" y="1645920"/>
-            <a:ext cx="3611880" cy="4389120"/>
-          </a:xfrm>
-          <a:prstGeom prst="rect">
-            <a:avLst/>
-          </a:prstGeom>
-          <a:solidFill>
-            <a:srgbClr val="12161A"/>
-          </a:solidFill>
-          <a:ln w="12700">
-            <a:solidFill>
-              <a:srgbClr val="232A31"/>
-            </a:solidFill>
-            <a:prstDash val="solid"/>
-          </a:ln>
-        </p:spPr>
-      </p:sp>
-      <p:sp>
-        <p:nvSpPr>
-          <p:cNvPr id="34" name="col-top"/>
-          <p:cNvSpPr/>
-          <p:nvPr/>
-        </p:nvSpPr>
-        <p:spPr>
-          <a:xfrm>
-            <a:off x="8046720" y="1645920"/>
-            <a:ext cx="3611880" cy="64008"/>
-          </a:xfrm>
-          <a:prstGeom prst="rect">
-            <a:avLst/>
-          </a:prstGeom>
-          <a:solidFill>
-            <a:srgbClr val="5B8DB8"/>
-          </a:solidFill>
-          <a:ln/>
-        </p:spPr>
-      </p:sp>
-      <p:sp>
-        <p:nvSpPr>
-          <p:cNvPr id="35" name="Text 32"/>
-          <p:cNvSpPr txBox="1"/>
-          <p:nvPr/>
-        </p:nvSpPr>
-        <p:spPr>
-          <a:xfrm>
-            <a:off x="8275320" y="1874520"/>
-            <a:ext cx="3108960" cy="274320"/>
-          </a:xfrm>
-          <a:prstGeom prst="rect">
-            <a:avLst/>
-          </a:prstGeom>
-          <a:noFill/>
-          <a:ln/>
-        </p:spPr>
-        <p:txBody>
-          <a:bodyPr wrap="square" lIns="0" tIns="0" rIns="0" bIns="0" rtlCol="0" anchor="ctr"/>
-          <a:lstStyle/>
-          <a:p>
-            <a:pPr indent="0" marL="0">
-              <a:buNone/>
-            </a:pPr>
-            <a:r>
-              <a:rPr lang="en-US" sz="1200" b="1" spc="300" kern="0" dirty="0">
-                <a:solidFill>
-                  <a:srgbClr val="5B8DB8"/>
-                </a:solidFill>
-                <a:latin typeface="Courier New" pitchFamily="34" charset="0"/>
-                <a:ea typeface="Courier New" pitchFamily="34" charset="-122"/>
-                <a:cs typeface="Courier New" pitchFamily="34" charset="-120"/>
-              </a:rPr>
-              <a:t>NEXT</a:t>
-            </a:r>
-            <a:endParaRPr lang="en-US" sz="1200" dirty="0"/>
-          </a:p>
-        </p:txBody>
-      </p:sp>
-      <p:sp>
-        <p:nvSpPr>
-          <p:cNvPr id="36" name="dot"/>
-          <p:cNvSpPr/>
-          <p:nvPr/>
-        </p:nvSpPr>
-        <p:spPr>
-          <a:xfrm>
-            <a:off x="8275320" y="2423160"/>
-            <a:ext cx="91440" cy="91440"/>
-          </a:xfrm>
-          <a:prstGeom prst="rect">
-            <a:avLst/>
-          </a:prstGeom>
-          <a:solidFill>
-            <a:srgbClr val="5B8DB8"/>
-          </a:solidFill>
-          <a:ln/>
-        </p:spPr>
-      </p:sp>
-      <p:sp>
-        <p:nvSpPr>
-          <p:cNvPr id="37" name="Text 34"/>
-          <p:cNvSpPr txBox="1"/>
-          <p:nvPr/>
-        </p:nvSpPr>
-        <p:spPr>
-          <a:xfrm>
-            <a:off x="8531352" y="2331720"/>
-            <a:ext cx="2926080" cy="566928"/>
-          </a:xfrm>
-          <a:prstGeom prst="rect">
-            <a:avLst/>
-          </a:prstGeom>
-          <a:noFill/>
-          <a:ln/>
-        </p:spPr>
-        <p:txBody>
-          <a:bodyPr wrap="square" lIns="0" tIns="0" rIns="0" bIns="0" rtlCol="0" anchor="t"/>
-          <a:lstStyle/>
-          <a:p>
-            <a:pPr indent="0" marL="0">
-              <a:buNone/>
-            </a:pPr>
-            <a:r>
-              <a:rPr lang="en-US" sz="1350" dirty="0">
-                <a:solidFill>
-                  <a:srgbClr val="CBD2D9"/>
-                </a:solidFill>
-                <a:latin typeface="Calibri" pitchFamily="34" charset="0"/>
-                <a:ea typeface="Calibri" pitchFamily="34" charset="-122"/>
-                <a:cs typeface="Calibri" pitchFamily="34" charset="-120"/>
-              </a:rPr>
-              <a:t>Autoencoder for novel traffic</a:t>
-            </a:r>
-            <a:endParaRPr lang="en-US" sz="1350" dirty="0"/>
-          </a:p>
-        </p:txBody>
-      </p:sp>
-      <p:sp>
-        <p:nvSpPr>
-          <p:cNvPr id="38" name="dot"/>
-          <p:cNvSpPr/>
-          <p:nvPr/>
-        </p:nvSpPr>
-        <p:spPr>
-          <a:xfrm>
-            <a:off x="8275320" y="3054096"/>
-            <a:ext cx="91440" cy="91440"/>
-          </a:xfrm>
-          <a:prstGeom prst="rect">
-            <a:avLst/>
-          </a:prstGeom>
-          <a:solidFill>
-            <a:srgbClr val="5B8DB8"/>
-          </a:solidFill>
-          <a:ln/>
-        </p:spPr>
-      </p:sp>
-      <p:sp>
-        <p:nvSpPr>
-          <p:cNvPr id="39" name="Text 36"/>
-          <p:cNvSpPr txBox="1"/>
-          <p:nvPr/>
-        </p:nvSpPr>
-        <p:spPr>
-          <a:xfrm>
-            <a:off x="8531352" y="2962656"/>
-            <a:ext cx="2926080" cy="566928"/>
-          </a:xfrm>
-          <a:prstGeom prst="rect">
-            <a:avLst/>
-          </a:prstGeom>
-          <a:noFill/>
-          <a:ln/>
-        </p:spPr>
-        <p:txBody>
-          <a:bodyPr wrap="square" lIns="0" tIns="0" rIns="0" bIns="0" rtlCol="0" anchor="t"/>
-          <a:lstStyle/>
-          <a:p>
-            <a:pPr indent="0" marL="0">
-              <a:buNone/>
-            </a:pPr>
-            <a:r>
-              <a:rPr lang="en-US" sz="1350" dirty="0">
-                <a:solidFill>
-                  <a:srgbClr val="CBD2D9"/>
-                </a:solidFill>
-                <a:latin typeface="Calibri" pitchFamily="34" charset="0"/>
-                <a:ea typeface="Calibri" pitchFamily="34" charset="-122"/>
-                <a:cs typeface="Calibri" pitchFamily="34" charset="-120"/>
-              </a:rPr>
-              <a:t>Per-device peer baselines</a:t>
-            </a:r>
-            <a:endParaRPr lang="en-US" sz="1350" dirty="0"/>
-          </a:p>
-        </p:txBody>
-      </p:sp>
-      <p:sp>
-        <p:nvSpPr>
-          <p:cNvPr id="40" name="dot"/>
-          <p:cNvSpPr/>
-          <p:nvPr/>
-        </p:nvSpPr>
-        <p:spPr>
-          <a:xfrm>
-            <a:off x="8275320" y="3685032"/>
-            <a:ext cx="91440" cy="91440"/>
-          </a:xfrm>
-          <a:prstGeom prst="rect">
-            <a:avLst/>
-          </a:prstGeom>
-          <a:solidFill>
-            <a:srgbClr val="5B8DB8"/>
-          </a:solidFill>
-          <a:ln/>
-        </p:spPr>
-      </p:sp>
-      <p:sp>
-        <p:nvSpPr>
-          <p:cNvPr id="41" name="Text 38"/>
-          <p:cNvSpPr txBox="1"/>
-          <p:nvPr/>
-        </p:nvSpPr>
-        <p:spPr>
-          <a:xfrm>
-            <a:off x="8531352" y="3593592"/>
-            <a:ext cx="2926080" cy="566928"/>
-          </a:xfrm>
-          <a:prstGeom prst="rect">
-            <a:avLst/>
-          </a:prstGeom>
-          <a:noFill/>
-          <a:ln/>
-        </p:spPr>
-        <p:txBody>
-          <a:bodyPr wrap="square" lIns="0" tIns="0" rIns="0" bIns="0" rtlCol="0" anchor="t"/>
-          <a:lstStyle/>
-          <a:p>
-            <a:pPr indent="0" marL="0">
-              <a:buNone/>
-            </a:pPr>
-            <a:r>
-              <a:rPr lang="en-US" sz="1350" dirty="0">
-                <a:solidFill>
-                  <a:srgbClr val="CBD2D9"/>
-                </a:solidFill>
-                <a:latin typeface="Calibri" pitchFamily="34" charset="0"/>
-                <a:ea typeface="Calibri" pitchFamily="34" charset="-122"/>
-                <a:cs typeface="Calibri" pitchFamily="34" charset="-120"/>
-              </a:rPr>
-              <a:t>Blocking, with human approval</a:t>
-            </a:r>
-            <a:endParaRPr lang="en-US" sz="1350" dirty="0"/>
-          </a:p>
-        </p:txBody>
-      </p:sp>
-      <p:sp>
-        <p:nvSpPr>
-          <p:cNvPr id="42" name="dot"/>
-          <p:cNvSpPr/>
-          <p:nvPr/>
-        </p:nvSpPr>
-        <p:spPr>
-          <a:xfrm>
-            <a:off x="8275320" y="4315968"/>
-            <a:ext cx="91440" cy="91440"/>
-          </a:xfrm>
-          <a:prstGeom prst="rect">
-            <a:avLst/>
-          </a:prstGeom>
-          <a:solidFill>
-            <a:srgbClr val="5B8DB8"/>
-          </a:solidFill>
-          <a:ln/>
-        </p:spPr>
-      </p:sp>
-      <p:sp>
-        <p:nvSpPr>
-          <p:cNvPr id="43" name="Text 40"/>
-          <p:cNvSpPr txBox="1"/>
-          <p:nvPr/>
-        </p:nvSpPr>
-        <p:spPr>
-          <a:xfrm>
-            <a:off x="8531352" y="4224528"/>
-            <a:ext cx="2926080" cy="566928"/>
-          </a:xfrm>
-          <a:prstGeom prst="rect">
-            <a:avLst/>
-          </a:prstGeom>
-          <a:noFill/>
-          <a:ln/>
-        </p:spPr>
-        <p:txBody>
-          <a:bodyPr wrap="square" lIns="0" tIns="0" rIns="0" bIns="0" rtlCol="0" anchor="t"/>
-          <a:lstStyle/>
-          <a:p>
-            <a:pPr indent="0" marL="0">
-              <a:buNone/>
-            </a:pPr>
-            <a:r>
-              <a:rPr lang="en-US" sz="1350" dirty="0">
-                <a:solidFill>
-                  <a:srgbClr val="CBD2D9"/>
-                </a:solidFill>
-                <a:latin typeface="Calibri" pitchFamily="34" charset="0"/>
-                <a:ea typeface="Calibri" pitchFamily="34" charset="-122"/>
-                <a:cs typeface="Calibri" pitchFamily="34" charset="-120"/>
-              </a:rPr>
-              <a:t>A background service (launchd)</a:t>
-            </a:r>
-            <a:endParaRPr lang="en-US" sz="1350" dirty="0"/>
-          </a:p>
-        </p:txBody>
-      </p:sp>
-      <p:sp>
-        <p:nvSpPr>
-          <p:cNvPr id="44" name="dot"/>
-          <p:cNvSpPr/>
-          <p:nvPr/>
-        </p:nvSpPr>
-        <p:spPr>
-          <a:xfrm>
-            <a:off x="8275320" y="4946904"/>
-            <a:ext cx="91440" cy="91440"/>
-          </a:xfrm>
-          <a:prstGeom prst="rect">
-            <a:avLst/>
-          </a:prstGeom>
-          <a:solidFill>
-            <a:srgbClr val="5B8DB8"/>
-          </a:solidFill>
-          <a:ln/>
-        </p:spPr>
-      </p:sp>
-      <p:sp>
-        <p:nvSpPr>
-          <p:cNvPr id="45" name="Text 42"/>
-          <p:cNvSpPr txBox="1"/>
-          <p:nvPr/>
-        </p:nvSpPr>
-        <p:spPr>
-          <a:xfrm>
-            <a:off x="8531352" y="4855464"/>
-            <a:ext cx="2926080" cy="566928"/>
-          </a:xfrm>
-          <a:prstGeom prst="rect">
-            <a:avLst/>
-          </a:prstGeom>
-          <a:noFill/>
-          <a:ln/>
-        </p:spPr>
-        <p:txBody>
-          <a:bodyPr wrap="square" lIns="0" tIns="0" rIns="0" bIns="0" rtlCol="0" anchor="t"/>
-          <a:lstStyle/>
-          <a:p>
-            <a:pPr indent="0" marL="0">
-              <a:buNone/>
-            </a:pPr>
-            <a:r>
-              <a:rPr lang="en-US" sz="1350" dirty="0">
-                <a:solidFill>
-                  <a:srgbClr val="CBD2D9"/>
-                </a:solidFill>
-                <a:latin typeface="Calibri" pitchFamily="34" charset="0"/>
-                <a:ea typeface="Calibri" pitchFamily="34" charset="-122"/>
-                <a:cs typeface="Calibri" pitchFamily="34" charset="-120"/>
-              </a:rPr>
-              <a:t>Linux support</a:t>
-            </a:r>
-            <a:endParaRPr lang="en-US" sz="1350" dirty="0"/>
-          </a:p>
-        </p:txBody>
-      </p:sp>
-      <p:sp>
-        <p:nvSpPr>
-          <p:cNvPr id="25" name="Slide Number Placeholder 0"/>
-          <p:cNvSpPr>
-            <a:spLocks noGrp="1"/>
-          </p:cNvSpPr>
-          <p:nvPr>
-            <p:ph type="sldNum" sz="quarter" idx="4294967295"/>
-          </p:nvPr>
-        </p:nvSpPr>
-        <p:spPr>
-          <a:xfrm>
-            <a:off x="10972800" y="6492240"/>
-            <a:ext cx="685800" cy="256032"/>
-          </a:xfrm>
-          <a:prstGeom prst="rect">
-            <a:avLst/>
-          </a:prstGeom>
-          <a:extLst>
-            <a:ext uri="{C572A759-6A51-4108-AA02-DFA0A04FC94B}">
-              <ma14:wrappingTextBoxFlag xmlns:ma14="http://schemas.microsoft.com/office/mac/drawingml/2011/main" val="0"/>
-            </a:ext>
-          </a:extLst>
-        </p:spPr>
-        <p:txBody>
-          <a:bodyPr/>
-          <a:lstStyle>
-            <a:lvl1pPr>
-              <a:defRPr sz="1000">
-                <a:solidFill>
-                  <a:srgbClr val="7B8794"/>
-                </a:solidFill>
-                <a:latin typeface="Courier New"/>
-                <a:ea typeface="Courier New"/>
-                <a:cs typeface="Courier New"/>
-              </a:defRPr>
-            </a:lvl1pPr>
-          </a:lstStyle>
-          <a:p>
-            <a:pPr algn="r"/>
-            <a:fld id="{F7021451-1387-4CA6-816F-3879F97B5CBC}" type="slidenum">
-              <a:rPr b="0" lang="en-US"/>
-              <a:t>16</a:t>
-            </a:fld>
-            <a:endParaRPr lang="en-US"/>
-          </a:p>
-        </p:txBody>
-      </p:sp>
-    </p:spTree>
-  </p:cSld>
-  <p:clrMapOvr>
-    <a:masterClrMapping/>
-  </p:clrMapOvr>
-</p:sld>
-</file>
-
-<file path=ppt/slides/slide17.xml><?xml version="1.0" encoding="utf-8"?>
-<p:sld xmlns:a="http://schemas.openxmlformats.org/drawingml/2006/main" xmlns:r="http://schemas.openxmlformats.org/officeDocument/2006/relationships" xmlns:p="http://schemas.openxmlformats.org/presentationml/2006/main">
-  <p:cSld name="Slide 17">
     <p:spTree>
       <p:nvGrpSpPr>
         <p:cNvPr id="1" name=""/>

</xml_diff>